<commit_message>
docs: correct workflow to match orchestrator, rewrite copy in a plainer voice
Workflow slide now mirrors runWorkflow exactly — Intake, Analysis, Negotiation,
Recruitment, Underwrite (with delegated re-underwrite tasks), then Memo + human
sign-off — and no longer shows negotiation as a dead-end branch or conflates the
optional counterfactual fork with the main flow. Reworked copy across all slides
to remove AI-isms (X-not-Y constructions, triads, jargon). Verified models are
genuinely three-provider (Gemini/Claude/GPT per role) and 26 tests.
</commit_message>
<xml_diff>
--- a/presentation/DueDiligenceOS.pptx
+++ b/presentation/DueDiligenceOS.pptx
@@ -2034,7 +2034,7 @@
       </p:grpSpPr>
       <p:pic>
         <p:nvPicPr>
-          <p:cNvPr id="2" name="Image 0" descr="/tmp/ddos-deck-v2/slide-01.png">    </p:cNvPr>
+          <p:cNvPr id="2" name="Image 0" descr="/Users/tasfirulhaque/Frooxi/Own/Hackathon/presentation/slide-01.png">    </p:cNvPr>
           <p:cNvPicPr>
             <a:picLocks noChangeAspect="1"/>
           </p:cNvPicPr>
@@ -2090,7 +2090,7 @@
       </p:grpSpPr>
       <p:pic>
         <p:nvPicPr>
-          <p:cNvPr id="2" name="Image 0" descr="/tmp/ddos-deck-v2/slide-10.png">    </p:cNvPr>
+          <p:cNvPr id="2" name="Image 0" descr="/Users/tasfirulhaque/Frooxi/Own/Hackathon/presentation/slide-10.png">    </p:cNvPr>
           <p:cNvPicPr>
             <a:picLocks noChangeAspect="1"/>
           </p:cNvPicPr>
@@ -2146,7 +2146,7 @@
       </p:grpSpPr>
       <p:pic>
         <p:nvPicPr>
-          <p:cNvPr id="2" name="Image 0" descr="/tmp/ddos-deck-v2/slide-11.png">    </p:cNvPr>
+          <p:cNvPr id="2" name="Image 0" descr="/Users/tasfirulhaque/Frooxi/Own/Hackathon/presentation/slide-11.png">    </p:cNvPr>
           <p:cNvPicPr>
             <a:picLocks noChangeAspect="1"/>
           </p:cNvPicPr>
@@ -2202,7 +2202,7 @@
       </p:grpSpPr>
       <p:pic>
         <p:nvPicPr>
-          <p:cNvPr id="2" name="Image 0" descr="/tmp/ddos-deck-v2/slide-12.png">    </p:cNvPr>
+          <p:cNvPr id="2" name="Image 0" descr="/Users/tasfirulhaque/Frooxi/Own/Hackathon/presentation/slide-12.png">    </p:cNvPr>
           <p:cNvPicPr>
             <a:picLocks noChangeAspect="1"/>
           </p:cNvPicPr>
@@ -2258,7 +2258,7 @@
       </p:grpSpPr>
       <p:pic>
         <p:nvPicPr>
-          <p:cNvPr id="2" name="Image 0" descr="/tmp/ddos-deck-v2/slide-13.png">    </p:cNvPr>
+          <p:cNvPr id="2" name="Image 0" descr="/Users/tasfirulhaque/Frooxi/Own/Hackathon/presentation/slide-13.png">    </p:cNvPr>
           <p:cNvPicPr>
             <a:picLocks noChangeAspect="1"/>
           </p:cNvPicPr>
@@ -2314,7 +2314,7 @@
       </p:grpSpPr>
       <p:pic>
         <p:nvPicPr>
-          <p:cNvPr id="2" name="Image 0" descr="/tmp/ddos-deck-v2/slide-14.png">    </p:cNvPr>
+          <p:cNvPr id="2" name="Image 0" descr="/Users/tasfirulhaque/Frooxi/Own/Hackathon/presentation/slide-14.png">    </p:cNvPr>
           <p:cNvPicPr>
             <a:picLocks noChangeAspect="1"/>
           </p:cNvPicPr>
@@ -2370,7 +2370,7 @@
       </p:grpSpPr>
       <p:pic>
         <p:nvPicPr>
-          <p:cNvPr id="2" name="Image 0" descr="/tmp/ddos-deck-v2/slide-02.png">    </p:cNvPr>
+          <p:cNvPr id="2" name="Image 0" descr="/Users/tasfirulhaque/Frooxi/Own/Hackathon/presentation/slide-02.png">    </p:cNvPr>
           <p:cNvPicPr>
             <a:picLocks noChangeAspect="1"/>
           </p:cNvPicPr>
@@ -2426,7 +2426,7 @@
       </p:grpSpPr>
       <p:pic>
         <p:nvPicPr>
-          <p:cNvPr id="2" name="Image 0" descr="/tmp/ddos-deck-v2/slide-03.png">    </p:cNvPr>
+          <p:cNvPr id="2" name="Image 0" descr="/Users/tasfirulhaque/Frooxi/Own/Hackathon/presentation/slide-03.png">    </p:cNvPr>
           <p:cNvPicPr>
             <a:picLocks noChangeAspect="1"/>
           </p:cNvPicPr>
@@ -2482,7 +2482,7 @@
       </p:grpSpPr>
       <p:pic>
         <p:nvPicPr>
-          <p:cNvPr id="2" name="Image 0" descr="/tmp/ddos-deck-v2/slide-04.png">    </p:cNvPr>
+          <p:cNvPr id="2" name="Image 0" descr="/Users/tasfirulhaque/Frooxi/Own/Hackathon/presentation/slide-04.png">    </p:cNvPr>
           <p:cNvPicPr>
             <a:picLocks noChangeAspect="1"/>
           </p:cNvPicPr>
@@ -2538,7 +2538,7 @@
       </p:grpSpPr>
       <p:pic>
         <p:nvPicPr>
-          <p:cNvPr id="2" name="Image 0" descr="/tmp/ddos-deck-v2/slide-05.png">    </p:cNvPr>
+          <p:cNvPr id="2" name="Image 0" descr="/Users/tasfirulhaque/Frooxi/Own/Hackathon/presentation/slide-05.png">    </p:cNvPr>
           <p:cNvPicPr>
             <a:picLocks noChangeAspect="1"/>
           </p:cNvPicPr>
@@ -2594,7 +2594,7 @@
       </p:grpSpPr>
       <p:pic>
         <p:nvPicPr>
-          <p:cNvPr id="2" name="Image 0" descr="/tmp/ddos-deck-v2/slide-06.png">    </p:cNvPr>
+          <p:cNvPr id="2" name="Image 0" descr="/Users/tasfirulhaque/Frooxi/Own/Hackathon/presentation/slide-06.png">    </p:cNvPr>
           <p:cNvPicPr>
             <a:picLocks noChangeAspect="1"/>
           </p:cNvPicPr>
@@ -2650,7 +2650,7 @@
       </p:grpSpPr>
       <p:pic>
         <p:nvPicPr>
-          <p:cNvPr id="2" name="Image 0" descr="/tmp/ddos-deck-v2/slide-07.png">    </p:cNvPr>
+          <p:cNvPr id="2" name="Image 0" descr="/Users/tasfirulhaque/Frooxi/Own/Hackathon/presentation/slide-07.png">    </p:cNvPr>
           <p:cNvPicPr>
             <a:picLocks noChangeAspect="1"/>
           </p:cNvPicPr>
@@ -2706,7 +2706,7 @@
       </p:grpSpPr>
       <p:pic>
         <p:nvPicPr>
-          <p:cNvPr id="2" name="Image 0" descr="/tmp/ddos-deck-v2/slide-08.png">    </p:cNvPr>
+          <p:cNvPr id="2" name="Image 0" descr="/Users/tasfirulhaque/Frooxi/Own/Hackathon/presentation/slide-08.png">    </p:cNvPr>
           <p:cNvPicPr>
             <a:picLocks noChangeAspect="1"/>
           </p:cNvPicPr>
@@ -2762,7 +2762,7 @@
       </p:grpSpPr>
       <p:pic>
         <p:nvPicPr>
-          <p:cNvPr id="2" name="Image 0" descr="/tmp/ddos-deck-v2/slide-09.png">    </p:cNvPr>
+          <p:cNvPr id="2" name="Image 0" descr="/Users/tasfirulhaque/Frooxi/Own/Hackathon/presentation/slide-09.png">    </p:cNvPr>
           <p:cNvPicPr>
             <a:picLocks noChangeAspect="1"/>
           </p:cNvPicPr>

</xml_diff>